<commit_message>
Localize sales deck for Afghan Dari
</commit_message>
<xml_diff>
--- a/presentation/flooring-vinyl-store-manager.pptx
+++ b/presentation/flooring-vinyl-store-manager.pptx
@@ -3169,7 +3169,7 @@
           </a:bodyPr>
           <a:lstStyle/>
           <a:p>
-            <a:pPr>
+            <a:pPr algn="r" rtl="1">
               <a:spcAft>
                 <a:spcPts val="200"/>
               </a:spcAft>
@@ -3177,11 +3177,11 @@
                 <a:solidFill>
                   <a:srgbClr val="D7E6DC"/>
                 </a:solidFill>
-                <a:latin typeface="Aptos"/>
-              </a:defRPr>
-            </a:pPr>
-            <a:r>
-              <a:t>A CLEARER WAY TO RUN YOUR STORE</a:t>
+                <a:latin typeface="Tahoma"/>
+              </a:defRPr>
+            </a:pPr>
+            <a:r>
+              <a:t>راه ساده‌تر برای مدیریت دکان شما</a:t>
             </a:r>
           </a:p>
         </p:txBody>
@@ -3208,7 +3208,7 @@
           </a:bodyPr>
           <a:lstStyle/>
           <a:p>
-            <a:pPr>
+            <a:pPr algn="r" rtl="1">
               <a:spcAft>
                 <a:spcPts val="200"/>
               </a:spcAft>
@@ -3216,15 +3216,15 @@
                 <a:solidFill>
                   <a:srgbClr val="FFFFFF"/>
                 </a:solidFill>
-                <a:latin typeface="Aptos"/>
-              </a:defRPr>
-            </a:pPr>
-            <a:r>
-              <a:t>Every roll.</a:t>
-            </a:r>
-          </a:p>
-          <a:p>
-            <a:pPr>
+                <a:latin typeface="Tahoma"/>
+              </a:defRPr>
+            </a:pPr>
+            <a:r>
+              <a:t>هر رول،</a:t>
+            </a:r>
+          </a:p>
+          <a:p>
+            <a:pPr algn="r" rtl="1">
               <a:spcAft>
                 <a:spcPts val="200"/>
               </a:spcAft>
@@ -3232,15 +3232,15 @@
                 <a:solidFill>
                   <a:srgbClr val="FFFFFF"/>
                 </a:solidFill>
-                <a:latin typeface="Aptos"/>
-              </a:defRPr>
-            </a:pPr>
-            <a:r>
-              <a:t>Every sale.</a:t>
-            </a:r>
-          </a:p>
-          <a:p>
-            <a:pPr>
+                <a:latin typeface="Tahoma"/>
+              </a:defRPr>
+            </a:pPr>
+            <a:r>
+              <a:t>هر فروش،</a:t>
+            </a:r>
+          </a:p>
+          <a:p>
+            <a:pPr algn="r" rtl="1">
               <a:spcAft>
                 <a:spcPts val="200"/>
               </a:spcAft>
@@ -3248,11 +3248,11 @@
                 <a:solidFill>
                   <a:srgbClr val="FFFFFF"/>
                 </a:solidFill>
-                <a:latin typeface="Aptos"/>
-              </a:defRPr>
-            </a:pPr>
-            <a:r>
-              <a:t>All in one place.</a:t>
+                <a:latin typeface="Tahoma"/>
+              </a:defRPr>
+            </a:pPr>
+            <a:r>
+              <a:t>همه در یک‌جا.</a:t>
             </a:r>
           </a:p>
         </p:txBody>
@@ -3279,7 +3279,7 @@
           </a:bodyPr>
           <a:lstStyle/>
           <a:p>
-            <a:pPr>
+            <a:pPr algn="r" rtl="1">
               <a:spcAft>
                 <a:spcPts val="200"/>
               </a:spcAft>
@@ -3287,11 +3287,11 @@
                 <a:solidFill>
                   <a:srgbClr val="DDE9DF"/>
                 </a:solidFill>
-                <a:latin typeface="Aptos"/>
-              </a:defRPr>
-            </a:pPr>
-            <a:r>
-              <a:t>Flooring &amp; Vinyl Store Manager</a:t>
+                <a:latin typeface="Tahoma"/>
+              </a:defRPr>
+            </a:pPr>
+            <a:r>
+              <a:t>سیستم مدیریت دکان قالین و وینیل</a:t>
             </a:r>
           </a:p>
         </p:txBody>
@@ -3318,7 +3318,7 @@
           </a:bodyPr>
           <a:lstStyle/>
           <a:p>
-            <a:pPr>
+            <a:pPr algn="r" rtl="1">
               <a:spcAft>
                 <a:spcPts val="200"/>
               </a:spcAft>
@@ -3326,11 +3326,11 @@
                 <a:solidFill>
                   <a:srgbClr val="B7CCBE"/>
                 </a:solidFill>
-                <a:latin typeface="Aptos"/>
-              </a:defRPr>
-            </a:pPr>
-            <a:r>
-              <a:t>Stock • Sales • Customer accounts • Suppliers</a:t>
+                <a:latin typeface="Tahoma"/>
+              </a:defRPr>
+            </a:pPr>
+            <a:r>
+              <a:t>موجودی • فروشات • حساب مشتریان • تهیه‌کنندگان</a:t>
             </a:r>
           </a:p>
         </p:txBody>
@@ -3473,7 +3473,7 @@
           </a:bodyPr>
           <a:lstStyle/>
           <a:p>
-            <a:pPr>
+            <a:pPr algn="r" rtl="1">
               <a:spcAft>
                 <a:spcPts val="200"/>
               </a:spcAft>
@@ -3481,11 +3481,11 @@
                 <a:solidFill>
                   <a:srgbClr val="A8C1B1"/>
                 </a:solidFill>
-                <a:latin typeface="Aptos"/>
-              </a:defRPr>
-            </a:pPr>
-            <a:r>
-              <a:t>REAL APP SCREEN</a:t>
+                <a:latin typeface="Tahoma"/>
+              </a:defRPr>
+            </a:pPr>
+            <a:r>
+              <a:t>تصویر از محیط برنامه</a:t>
             </a:r>
           </a:p>
         </p:txBody>
@@ -3512,7 +3512,7 @@
           </a:bodyPr>
           <a:lstStyle/>
           <a:p>
-            <a:pPr algn="r">
+            <a:pPr algn="r" rtl="1">
               <a:spcAft>
                 <a:spcPts val="200"/>
               </a:spcAft>
@@ -3520,7 +3520,7 @@
                 <a:solidFill>
                   <a:srgbClr val="A8C1B1"/>
                 </a:solidFill>
-                <a:latin typeface="Aptos"/>
+                <a:latin typeface="Tahoma"/>
               </a:defRPr>
             </a:pPr>
             <a:r>
@@ -3577,7 +3577,7 @@
           </a:bodyPr>
           <a:lstStyle/>
           <a:p>
-            <a:pPr>
+            <a:pPr algn="r" rtl="1">
               <a:spcAft>
                 <a:spcPts val="200"/>
               </a:spcAft>
@@ -3585,11 +3585,11 @@
                 <a:solidFill>
                   <a:srgbClr val="1F5948"/>
                 </a:solidFill>
-                <a:latin typeface="Aptos"/>
-              </a:defRPr>
-            </a:pPr>
-            <a:r>
-              <a:t>01  /  INVENTORY</a:t>
+                <a:latin typeface="Tahoma"/>
+              </a:defRPr>
+            </a:pPr>
+            <a:r>
+              <a:t>01  /  موجودی</a:t>
             </a:r>
           </a:p>
         </p:txBody>
@@ -3616,7 +3616,7 @@
           </a:bodyPr>
           <a:lstStyle/>
           <a:p>
-            <a:pPr>
+            <a:pPr algn="r" rtl="1">
               <a:spcAft>
                 <a:spcPts val="200"/>
               </a:spcAft>
@@ -3624,11 +3624,11 @@
                 <a:solidFill>
                   <a:srgbClr val="18352D"/>
                 </a:solidFill>
-                <a:latin typeface="Aptos"/>
-              </a:defRPr>
-            </a:pPr>
-            <a:r>
-              <a:t>Know what is on the shelf.</a:t>
+                <a:latin typeface="Tahoma"/>
+              </a:defRPr>
+            </a:pPr>
+            <a:r>
+              <a:t>از موجودی دکان‌تان دقیق باخبر باشید.</a:t>
             </a:r>
           </a:p>
         </p:txBody>
@@ -3655,7 +3655,7 @@
           </a:bodyPr>
           <a:lstStyle/>
           <a:p>
-            <a:pPr>
+            <a:pPr algn="r" rtl="1">
               <a:spcAft>
                 <a:spcPts val="200"/>
               </a:spcAft>
@@ -3663,11 +3663,11 @@
                 <a:solidFill>
                   <a:srgbClr val="66766F"/>
                 </a:solidFill>
-                <a:latin typeface="Aptos"/>
-              </a:defRPr>
-            </a:pPr>
-            <a:r>
-              <a:t>Track the stock you actually sell: individual rolls and the meters left on each one.</a:t>
+                <a:latin typeface="Tahoma"/>
+              </a:defRPr>
+            </a:pPr>
+            <a:r>
+              <a:t>هر رول را جداگانه ثبت کنید و طول باقی‌ماندهٔ آن را بدانید.</a:t>
             </a:r>
           </a:p>
         </p:txBody>
@@ -3739,7 +3739,7 @@
           </a:bodyPr>
           <a:lstStyle/>
           <a:p>
-            <a:pPr algn="ctr">
+            <a:pPr algn="ctr" rtl="1">
               <a:spcAft>
                 <a:spcPts val="200"/>
               </a:spcAft>
@@ -3747,7 +3747,7 @@
                 <a:solidFill>
                   <a:srgbClr val="1F5948"/>
                 </a:solidFill>
-                <a:latin typeface="Aptos"/>
+                <a:latin typeface="Tahoma"/>
               </a:defRPr>
             </a:pPr>
             <a:r>
@@ -3778,7 +3778,7 @@
           </a:bodyPr>
           <a:lstStyle/>
           <a:p>
-            <a:pPr>
+            <a:pPr algn="r" rtl="1">
               <a:spcAft>
                 <a:spcPts val="200"/>
               </a:spcAft>
@@ -3786,11 +3786,11 @@
                 <a:solidFill>
                   <a:srgbClr val="18352D"/>
                 </a:solidFill>
-                <a:latin typeface="Aptos"/>
-              </a:defRPr>
-            </a:pPr>
-            <a:r>
-              <a:t>Receive stock in batches</a:t>
+                <a:latin typeface="Tahoma"/>
+              </a:defRPr>
+            </a:pPr>
+            <a:r>
+              <a:t>رسیدن اجناس را یک‌جا ثبت کنید</a:t>
             </a:r>
           </a:p>
         </p:txBody>
@@ -3817,7 +3817,7 @@
           </a:bodyPr>
           <a:lstStyle/>
           <a:p>
-            <a:pPr>
+            <a:pPr algn="r" rtl="1">
               <a:spcAft>
                 <a:spcPts val="200"/>
               </a:spcAft>
@@ -3825,11 +3825,11 @@
                 <a:solidFill>
                   <a:srgbClr val="66766F"/>
                 </a:solidFill>
-                <a:latin typeface="Aptos"/>
-              </a:defRPr>
-            </a:pPr>
-            <a:r>
-              <a:t>Add a full delivery together, including supplier, colors, sizes and costs.</a:t>
+                <a:latin typeface="Tahoma"/>
+              </a:defRPr>
+            </a:pPr>
+            <a:r>
+              <a:t>تهیه‌کننده، رنگ، اندازه و مصارف هر محموله را وارد کنید.</a:t>
             </a:r>
           </a:p>
         </p:txBody>
@@ -3901,7 +3901,7 @@
           </a:bodyPr>
           <a:lstStyle/>
           <a:p>
-            <a:pPr algn="ctr">
+            <a:pPr algn="ctr" rtl="1">
               <a:spcAft>
                 <a:spcPts val="200"/>
               </a:spcAft>
@@ -3909,7 +3909,7 @@
                 <a:solidFill>
                   <a:srgbClr val="1F5948"/>
                 </a:solidFill>
-                <a:latin typeface="Aptos"/>
+                <a:latin typeface="Tahoma"/>
               </a:defRPr>
             </a:pPr>
             <a:r>
@@ -3940,7 +3940,7 @@
           </a:bodyPr>
           <a:lstStyle/>
           <a:p>
-            <a:pPr>
+            <a:pPr algn="r" rtl="1">
               <a:spcAft>
                 <a:spcPts val="200"/>
               </a:spcAft>
@@ -3948,11 +3948,11 @@
                 <a:solidFill>
                   <a:srgbClr val="18352D"/>
                 </a:solidFill>
-                <a:latin typeface="Aptos"/>
-              </a:defRPr>
-            </a:pPr>
-            <a:r>
-              <a:t>Keep every roll distinct</a:t>
+                <a:latin typeface="Tahoma"/>
+              </a:defRPr>
+            </a:pPr>
+            <a:r>
+              <a:t>هر رول را جداگانه نگه دارید</a:t>
             </a:r>
           </a:p>
         </p:txBody>
@@ -3979,7 +3979,7 @@
           </a:bodyPr>
           <a:lstStyle/>
           <a:p>
-            <a:pPr>
+            <a:pPr algn="r" rtl="1">
               <a:spcAft>
                 <a:spcPts val="200"/>
               </a:spcAft>
@@ -3987,11 +3987,11 @@
                 <a:solidFill>
                   <a:srgbClr val="66766F"/>
                 </a:solidFill>
-                <a:latin typeface="Aptos"/>
-              </a:defRPr>
-            </a:pPr>
-            <a:r>
-              <a:t>Each roll gets its own record and remaining length—even when rolls differ.</a:t>
+                <a:latin typeface="Tahoma"/>
+              </a:defRPr>
+            </a:pPr>
+            <a:r>
+              <a:t>برای هر رول یک ثبت جدا و طول باقی‌ماندهٔ آن را داشته باشید.</a:t>
             </a:r>
           </a:p>
         </p:txBody>
@@ -4063,7 +4063,7 @@
           </a:bodyPr>
           <a:lstStyle/>
           <a:p>
-            <a:pPr algn="ctr">
+            <a:pPr algn="ctr" rtl="1">
               <a:spcAft>
                 <a:spcPts val="200"/>
               </a:spcAft>
@@ -4071,7 +4071,7 @@
                 <a:solidFill>
                   <a:srgbClr val="1F5948"/>
                 </a:solidFill>
-                <a:latin typeface="Aptos"/>
+                <a:latin typeface="Tahoma"/>
               </a:defRPr>
             </a:pPr>
             <a:r>
@@ -4102,7 +4102,7 @@
           </a:bodyPr>
           <a:lstStyle/>
           <a:p>
-            <a:pPr>
+            <a:pPr algn="r" rtl="1">
               <a:spcAft>
                 <a:spcPts val="200"/>
               </a:spcAft>
@@ -4110,11 +4110,11 @@
                 <a:solidFill>
                   <a:srgbClr val="18352D"/>
                 </a:solidFill>
-                <a:latin typeface="Aptos"/>
-              </a:defRPr>
-            </a:pPr>
-            <a:r>
-              <a:t>Find the next action</a:t>
+                <a:latin typeface="Tahoma"/>
+              </a:defRPr>
+            </a:pPr>
+            <a:r>
+              <a:t>کمبود موجودی را زود ببینید</a:t>
             </a:r>
           </a:p>
         </p:txBody>
@@ -4141,7 +4141,7 @@
           </a:bodyPr>
           <a:lstStyle/>
           <a:p>
-            <a:pPr>
+            <a:pPr algn="r" rtl="1">
               <a:spcAft>
                 <a:spcPts val="200"/>
               </a:spcAft>
@@ -4149,11 +4149,11 @@
                 <a:solidFill>
                   <a:srgbClr val="66766F"/>
                 </a:solidFill>
-                <a:latin typeface="Aptos"/>
-              </a:defRPr>
-            </a:pPr>
-            <a:r>
-              <a:t>See available stock and low-stock items from the store dashboard.</a:t>
+                <a:latin typeface="Tahoma"/>
+              </a:defRPr>
+            </a:pPr>
+            <a:r>
+              <a:t>موجودی آمادهٔ فروش و رول‌های کم‌موجود را از داشبورد بررسی کنید.</a:t>
             </a:r>
           </a:p>
         </p:txBody>
@@ -4225,7 +4225,7 @@
           </a:bodyPr>
           <a:lstStyle/>
           <a:p>
-            <a:pPr>
+            <a:pPr algn="r" rtl="1">
               <a:spcAft>
                 <a:spcPts val="200"/>
               </a:spcAft>
@@ -4233,11 +4233,11 @@
                 <a:solidFill>
                   <a:srgbClr val="FFFFFF"/>
                 </a:solidFill>
-                <a:latin typeface="Aptos"/>
-              </a:defRPr>
-            </a:pPr>
-            <a:r>
-              <a:t>Fewer stock surprises</a:t>
+                <a:latin typeface="Tahoma"/>
+              </a:defRPr>
+            </a:pPr>
+            <a:r>
+              <a:t>موجودی دقیق‌تر، غافلگیری کمتر</a:t>
             </a:r>
           </a:p>
         </p:txBody>
@@ -4382,7 +4382,7 @@
           </a:bodyPr>
           <a:lstStyle/>
           <a:p>
-            <a:pPr>
+            <a:pPr algn="r" rtl="1">
               <a:spcAft>
                 <a:spcPts val="200"/>
               </a:spcAft>
@@ -4390,11 +4390,11 @@
                 <a:solidFill>
                   <a:srgbClr val="66766F"/>
                 </a:solidFill>
-                <a:latin typeface="Aptos"/>
-              </a:defRPr>
-            </a:pPr>
-            <a:r>
-              <a:t>Bulk delivery review • each roll is recorded separately</a:t>
+                <a:latin typeface="Tahoma"/>
+              </a:defRPr>
+            </a:pPr>
+            <a:r>
+              <a:t>بررسی محموله • هر رول به‌صورت جداگانه ثبت می‌شود</a:t>
             </a:r>
           </a:p>
         </p:txBody>
@@ -4421,7 +4421,7 @@
           </a:bodyPr>
           <a:lstStyle/>
           <a:p>
-            <a:pPr>
+            <a:pPr algn="r" rtl="1">
               <a:spcAft>
                 <a:spcPts val="200"/>
               </a:spcAft>
@@ -4429,11 +4429,11 @@
                 <a:solidFill>
                   <a:srgbClr val="66766F"/>
                 </a:solidFill>
-                <a:latin typeface="Aptos"/>
-              </a:defRPr>
-            </a:pPr>
-            <a:r>
-              <a:t>FLOORING &amp; VINYL STORE MANAGER</a:t>
+                <a:latin typeface="Tahoma"/>
+              </a:defRPr>
+            </a:pPr>
+            <a:r>
+              <a:t>سیستم مدیریت دکان قالین و وینیل</a:t>
             </a:r>
           </a:p>
         </p:txBody>
@@ -4460,7 +4460,7 @@
           </a:bodyPr>
           <a:lstStyle/>
           <a:p>
-            <a:pPr algn="r">
+            <a:pPr algn="r" rtl="1">
               <a:spcAft>
                 <a:spcPts val="200"/>
               </a:spcAft>
@@ -4468,7 +4468,7 @@
                 <a:solidFill>
                   <a:srgbClr val="66766F"/>
                 </a:solidFill>
-                <a:latin typeface="Aptos"/>
+                <a:latin typeface="Tahoma"/>
               </a:defRPr>
             </a:pPr>
             <a:r>
@@ -4525,7 +4525,7 @@
           </a:bodyPr>
           <a:lstStyle/>
           <a:p>
-            <a:pPr>
+            <a:pPr algn="r" rtl="1">
               <a:spcAft>
                 <a:spcPts val="200"/>
               </a:spcAft>
@@ -4533,11 +4533,11 @@
                 <a:solidFill>
                   <a:srgbClr val="1F5948"/>
                 </a:solidFill>
-                <a:latin typeface="Aptos"/>
-              </a:defRPr>
-            </a:pPr>
-            <a:r>
-              <a:t>02  /  CHECKOUT</a:t>
+                <a:latin typeface="Tahoma"/>
+              </a:defRPr>
+            </a:pPr>
+            <a:r>
+              <a:t>02  /  فروش</a:t>
             </a:r>
           </a:p>
         </p:txBody>
@@ -4564,7 +4564,7 @@
           </a:bodyPr>
           <a:lstStyle/>
           <a:p>
-            <a:pPr>
+            <a:pPr algn="r" rtl="1">
               <a:spcAft>
                 <a:spcPts val="200"/>
               </a:spcAft>
@@ -4572,11 +4572,11 @@
                 <a:solidFill>
                   <a:srgbClr val="18352D"/>
                 </a:solidFill>
-                <a:latin typeface="Aptos"/>
-              </a:defRPr>
-            </a:pPr>
-            <a:r>
-              <a:t>Make a complete sale in one bill.</a:t>
+                <a:latin typeface="Tahoma"/>
+              </a:defRPr>
+            </a:pPr>
+            <a:r>
+              <a:t>فروش را در یک بل به‌سادگی ثبت کنید.</a:t>
             </a:r>
           </a:p>
         </p:txBody>
@@ -4603,7 +4603,7 @@
           </a:bodyPr>
           <a:lstStyle/>
           <a:p>
-            <a:pPr>
+            <a:pPr algn="r" rtl="1">
               <a:spcAft>
                 <a:spcPts val="200"/>
               </a:spcAft>
@@ -4611,11 +4611,11 @@
                 <a:solidFill>
                   <a:srgbClr val="66766F"/>
                 </a:solidFill>
-                <a:latin typeface="Aptos"/>
-              </a:defRPr>
-            </a:pPr>
-            <a:r>
-              <a:t>Build a bill around the customer and the rolls they choose, then record payment once.</a:t>
+                <a:latin typeface="Tahoma"/>
+              </a:defRPr>
+            </a:pPr>
+            <a:r>
+              <a:t>مشتری و جنس‌های انتخاب‌شده را وارد کنید و پرداخت را یک‌بار ثبت نمایید.</a:t>
             </a:r>
           </a:p>
         </p:txBody>
@@ -4687,7 +4687,7 @@
           </a:bodyPr>
           <a:lstStyle/>
           <a:p>
-            <a:pPr algn="ctr">
+            <a:pPr algn="ctr" rtl="1">
               <a:spcAft>
                 <a:spcPts val="200"/>
               </a:spcAft>
@@ -4695,7 +4695,7 @@
                 <a:solidFill>
                   <a:srgbClr val="1F5948"/>
                 </a:solidFill>
-                <a:latin typeface="Aptos"/>
+                <a:latin typeface="Tahoma"/>
               </a:defRPr>
             </a:pPr>
             <a:r>
@@ -4726,7 +4726,7 @@
           </a:bodyPr>
           <a:lstStyle/>
           <a:p>
-            <a:pPr>
+            <a:pPr algn="r" rtl="1">
               <a:spcAft>
                 <a:spcPts val="200"/>
               </a:spcAft>
@@ -4734,11 +4734,11 @@
                 <a:solidFill>
                   <a:srgbClr val="18352D"/>
                 </a:solidFill>
-                <a:latin typeface="Aptos"/>
-              </a:defRPr>
-            </a:pPr>
-            <a:r>
-              <a:t>Add one or several rolls</a:t>
+                <a:latin typeface="Tahoma"/>
+              </a:defRPr>
+            </a:pPr>
+            <a:r>
+              <a:t>یک یا چند رول اضافه کنید</a:t>
             </a:r>
           </a:p>
         </p:txBody>
@@ -4765,7 +4765,7 @@
           </a:bodyPr>
           <a:lstStyle/>
           <a:p>
-            <a:pPr>
+            <a:pPr algn="r" rtl="1">
               <a:spcAft>
                 <a:spcPts val="200"/>
               </a:spcAft>
@@ -4773,11 +4773,11 @@
                 <a:solidFill>
                   <a:srgbClr val="66766F"/>
                 </a:solidFill>
-                <a:latin typeface="Aptos"/>
-              </a:defRPr>
-            </a:pPr>
-            <a:r>
-              <a:t>Set the length and price for each item on the same sale.</a:t>
+                <a:latin typeface="Tahoma"/>
+              </a:defRPr>
+            </a:pPr>
+            <a:r>
+              <a:t>طول و نرخ هر جنس را جداگانه در همان بل بنویسید.</a:t>
             </a:r>
           </a:p>
         </p:txBody>
@@ -4849,7 +4849,7 @@
           </a:bodyPr>
           <a:lstStyle/>
           <a:p>
-            <a:pPr algn="ctr">
+            <a:pPr algn="ctr" rtl="1">
               <a:spcAft>
                 <a:spcPts val="200"/>
               </a:spcAft>
@@ -4857,7 +4857,7 @@
                 <a:solidFill>
                   <a:srgbClr val="1F5948"/>
                 </a:solidFill>
-                <a:latin typeface="Aptos"/>
+                <a:latin typeface="Tahoma"/>
               </a:defRPr>
             </a:pPr>
             <a:r>
@@ -4888,7 +4888,7 @@
           </a:bodyPr>
           <a:lstStyle/>
           <a:p>
-            <a:pPr>
+            <a:pPr algn="r" rtl="1">
               <a:spcAft>
                 <a:spcPts val="200"/>
               </a:spcAft>
@@ -4896,11 +4896,11 @@
                 <a:solidFill>
                   <a:srgbClr val="18352D"/>
                 </a:solidFill>
-                <a:latin typeface="Aptos"/>
-              </a:defRPr>
-            </a:pPr>
-            <a:r>
-              <a:t>Let the app total the bill</a:t>
+                <a:latin typeface="Tahoma"/>
+              </a:defRPr>
+            </a:pPr>
+            <a:r>
+              <a:t>مجموع بل را خودکار ببینید</a:t>
             </a:r>
           </a:p>
         </p:txBody>
@@ -4927,7 +4927,7 @@
           </a:bodyPr>
           <a:lstStyle/>
           <a:p>
-            <a:pPr>
+            <a:pPr algn="r" rtl="1">
               <a:spcAft>
                 <a:spcPts val="200"/>
               </a:spcAft>
@@ -4935,11 +4935,11 @@
                 <a:solidFill>
                   <a:srgbClr val="66766F"/>
                 </a:solidFill>
-                <a:latin typeface="Aptos"/>
-              </a:defRPr>
-            </a:pPr>
-            <a:r>
-              <a:t>The bill brings item amounts, payment and amount due together.</a:t>
+                <a:latin typeface="Tahoma"/>
+              </a:defRPr>
+            </a:pPr>
+            <a:r>
+              <a:t>قیمت جنس‌ها، پرداخت و باقی‌داری در یک‌جا محاسبه می‌شود.</a:t>
             </a:r>
           </a:p>
         </p:txBody>
@@ -5011,7 +5011,7 @@
           </a:bodyPr>
           <a:lstStyle/>
           <a:p>
-            <a:pPr algn="ctr">
+            <a:pPr algn="ctr" rtl="1">
               <a:spcAft>
                 <a:spcPts val="200"/>
               </a:spcAft>
@@ -5019,7 +5019,7 @@
                 <a:solidFill>
                   <a:srgbClr val="1F5948"/>
                 </a:solidFill>
-                <a:latin typeface="Aptos"/>
+                <a:latin typeface="Tahoma"/>
               </a:defRPr>
             </a:pPr>
             <a:r>
@@ -5050,7 +5050,7 @@
           </a:bodyPr>
           <a:lstStyle/>
           <a:p>
-            <a:pPr>
+            <a:pPr algn="r" rtl="1">
               <a:spcAft>
                 <a:spcPts val="200"/>
               </a:spcAft>
@@ -5058,11 +5058,11 @@
                 <a:solidFill>
                   <a:srgbClr val="18352D"/>
                 </a:solidFill>
-                <a:latin typeface="Aptos"/>
-              </a:defRPr>
-            </a:pPr>
-            <a:r>
-              <a:t>Keep stock in sync</a:t>
+                <a:latin typeface="Tahoma"/>
+              </a:defRPr>
+            </a:pPr>
+            <a:r>
+              <a:t>موجودی را هم‌زمان به‌روز کنید</a:t>
             </a:r>
           </a:p>
         </p:txBody>
@@ -5089,7 +5089,7 @@
           </a:bodyPr>
           <a:lstStyle/>
           <a:p>
-            <a:pPr>
+            <a:pPr algn="r" rtl="1">
               <a:spcAft>
                 <a:spcPts val="200"/>
               </a:spcAft>
@@ -5097,11 +5097,11 @@
                 <a:solidFill>
                   <a:srgbClr val="66766F"/>
                 </a:solidFill>
-                <a:latin typeface="Aptos"/>
-              </a:defRPr>
-            </a:pPr>
-            <a:r>
-              <a:t>Sold lengths are deducted from the selected rolls.</a:t>
+                <a:latin typeface="Tahoma"/>
+              </a:defRPr>
+            </a:pPr>
+            <a:r>
+              <a:t>طول فروخته‌شده از رول انتخاب‌شده کم می‌شود.</a:t>
             </a:r>
           </a:p>
         </p:txBody>
@@ -5173,7 +5173,7 @@
           </a:bodyPr>
           <a:lstStyle/>
           <a:p>
-            <a:pPr>
+            <a:pPr algn="r" rtl="1">
               <a:spcAft>
                 <a:spcPts val="200"/>
               </a:spcAft>
@@ -5181,11 +5181,11 @@
                 <a:solidFill>
                   <a:srgbClr val="FFFFFF"/>
                 </a:solidFill>
-                <a:latin typeface="Aptos"/>
-              </a:defRPr>
-            </a:pPr>
-            <a:r>
-              <a:t>A smoother checkout</a:t>
+                <a:latin typeface="Tahoma"/>
+              </a:defRPr>
+            </a:pPr>
+            <a:r>
+              <a:t>فروش منظم و سریع‌تر</a:t>
             </a:r>
           </a:p>
         </p:txBody>
@@ -5330,7 +5330,7 @@
           </a:bodyPr>
           <a:lstStyle/>
           <a:p>
-            <a:pPr>
+            <a:pPr algn="r" rtl="1">
               <a:spcAft>
                 <a:spcPts val="200"/>
               </a:spcAft>
@@ -5338,11 +5338,11 @@
                 <a:solidFill>
                   <a:srgbClr val="66766F"/>
                 </a:solidFill>
-                <a:latin typeface="Aptos"/>
-              </a:defRPr>
-            </a:pPr>
-            <a:r>
-              <a:t>Multi-item sale screen • one customer, several items, one total</a:t>
+                <a:latin typeface="Tahoma"/>
+              </a:defRPr>
+            </a:pPr>
+            <a:r>
+              <a:t>صفحهٔ فروش چندجنسه • یک مشتری و چند جنس در یک بل</a:t>
             </a:r>
           </a:p>
         </p:txBody>
@@ -5369,7 +5369,7 @@
           </a:bodyPr>
           <a:lstStyle/>
           <a:p>
-            <a:pPr>
+            <a:pPr algn="r" rtl="1">
               <a:spcAft>
                 <a:spcPts val="200"/>
               </a:spcAft>
@@ -5377,11 +5377,11 @@
                 <a:solidFill>
                   <a:srgbClr val="66766F"/>
                 </a:solidFill>
-                <a:latin typeface="Aptos"/>
-              </a:defRPr>
-            </a:pPr>
-            <a:r>
-              <a:t>FLOORING &amp; VINYL STORE MANAGER</a:t>
+                <a:latin typeface="Tahoma"/>
+              </a:defRPr>
+            </a:pPr>
+            <a:r>
+              <a:t>سیستم مدیریت دکان قالین و وینیل</a:t>
             </a:r>
           </a:p>
         </p:txBody>
@@ -5408,7 +5408,7 @@
           </a:bodyPr>
           <a:lstStyle/>
           <a:p>
-            <a:pPr algn="r">
+            <a:pPr algn="r" rtl="1">
               <a:spcAft>
                 <a:spcPts val="200"/>
               </a:spcAft>
@@ -5416,7 +5416,7 @@
                 <a:solidFill>
                   <a:srgbClr val="66766F"/>
                 </a:solidFill>
-                <a:latin typeface="Aptos"/>
+                <a:latin typeface="Tahoma"/>
               </a:defRPr>
             </a:pPr>
             <a:r>
@@ -5473,7 +5473,7 @@
           </a:bodyPr>
           <a:lstStyle/>
           <a:p>
-            <a:pPr>
+            <a:pPr algn="r" rtl="1">
               <a:spcAft>
                 <a:spcPts val="200"/>
               </a:spcAft>
@@ -5481,11 +5481,11 @@
                 <a:solidFill>
                   <a:srgbClr val="1F5948"/>
                 </a:solidFill>
-                <a:latin typeface="Aptos"/>
-              </a:defRPr>
-            </a:pPr>
-            <a:r>
-              <a:t>03  /  CUSTOMER ACCOUNTS</a:t>
+                <a:latin typeface="Tahoma"/>
+              </a:defRPr>
+            </a:pPr>
+            <a:r>
+              <a:t>03  /  حساب مشتریان</a:t>
             </a:r>
           </a:p>
         </p:txBody>
@@ -5512,7 +5512,7 @@
           </a:bodyPr>
           <a:lstStyle/>
           <a:p>
-            <a:pPr>
+            <a:pPr algn="r" rtl="1">
               <a:spcAft>
                 <a:spcPts val="200"/>
               </a:spcAft>
@@ -5520,11 +5520,11 @@
                 <a:solidFill>
                   <a:srgbClr val="18352D"/>
                 </a:solidFill>
-                <a:latin typeface="Aptos"/>
-              </a:defRPr>
-            </a:pPr>
-            <a:r>
-              <a:t>Make every balance easy to explain.</a:t>
+                <a:latin typeface="Tahoma"/>
+              </a:defRPr>
+            </a:pPr>
+            <a:r>
+              <a:t>حساب هر مشتری را روشن و منظم نگه دارید.</a:t>
             </a:r>
           </a:p>
         </p:txBody>
@@ -5551,7 +5551,7 @@
           </a:bodyPr>
           <a:lstStyle/>
           <a:p>
-            <a:pPr>
+            <a:pPr algn="r" rtl="1">
               <a:spcAft>
                 <a:spcPts val="200"/>
               </a:spcAft>
@@ -5559,11 +5559,11 @@
                 <a:solidFill>
                   <a:srgbClr val="66766F"/>
                 </a:solidFill>
-                <a:latin typeface="Aptos"/>
-              </a:defRPr>
-            </a:pPr>
-            <a:r>
-              <a:t>Give customers a useful record of what they bought, what they paid and what remains due.</a:t>
+                <a:latin typeface="Tahoma"/>
+              </a:defRPr>
+            </a:pPr>
+            <a:r>
+              <a:t>خریدها، پرداخت‌ها و باقی‌داری مشتری را در یک سابقهٔ کامل ببینید.</a:t>
             </a:r>
           </a:p>
         </p:txBody>
@@ -5635,7 +5635,7 @@
           </a:bodyPr>
           <a:lstStyle/>
           <a:p>
-            <a:pPr algn="ctr">
+            <a:pPr algn="ctr" rtl="1">
               <a:spcAft>
                 <a:spcPts val="200"/>
               </a:spcAft>
@@ -5643,7 +5643,7 @@
                 <a:solidFill>
                   <a:srgbClr val="1F5948"/>
                 </a:solidFill>
-                <a:latin typeface="Aptos"/>
+                <a:latin typeface="Tahoma"/>
               </a:defRPr>
             </a:pPr>
             <a:r>
@@ -5674,7 +5674,7 @@
           </a:bodyPr>
           <a:lstStyle/>
           <a:p>
-            <a:pPr>
+            <a:pPr algn="r" rtl="1">
               <a:spcAft>
                 <a:spcPts val="200"/>
               </a:spcAft>
@@ -5682,11 +5682,11 @@
                 <a:solidFill>
                   <a:srgbClr val="18352D"/>
                 </a:solidFill>
-                <a:latin typeface="Aptos"/>
-              </a:defRPr>
-            </a:pPr>
-            <a:r>
-              <a:t>Open the full account history</a:t>
+                <a:latin typeface="Tahoma"/>
+              </a:defRPr>
+            </a:pPr>
+            <a:r>
+              <a:t>سابقهٔ حساب را یک‌جا ببینید</a:t>
             </a:r>
           </a:p>
         </p:txBody>
@@ -5713,7 +5713,7 @@
           </a:bodyPr>
           <a:lstStyle/>
           <a:p>
-            <a:pPr>
+            <a:pPr algn="r" rtl="1">
               <a:spcAft>
                 <a:spcPts val="200"/>
               </a:spcAft>
@@ -5721,11 +5721,11 @@
                 <a:solidFill>
                   <a:srgbClr val="66766F"/>
                 </a:solidFill>
-                <a:latin typeface="Aptos"/>
-              </a:defRPr>
-            </a:pPr>
-            <a:r>
-              <a:t>See purchases and later payments together in a customer statement.</a:t>
+                <a:latin typeface="Tahoma"/>
+              </a:defRPr>
+            </a:pPr>
+            <a:r>
+              <a:t>خریدها و رسیدهای بعدی در صورت‌حساب مشتری نمایش داده می‌شود.</a:t>
             </a:r>
           </a:p>
         </p:txBody>
@@ -5797,7 +5797,7 @@
           </a:bodyPr>
           <a:lstStyle/>
           <a:p>
-            <a:pPr algn="ctr">
+            <a:pPr algn="ctr" rtl="1">
               <a:spcAft>
                 <a:spcPts val="200"/>
               </a:spcAft>
@@ -5805,7 +5805,7 @@
                 <a:solidFill>
                   <a:srgbClr val="1F5948"/>
                 </a:solidFill>
-                <a:latin typeface="Aptos"/>
+                <a:latin typeface="Tahoma"/>
               </a:defRPr>
             </a:pPr>
             <a:r>
@@ -5836,7 +5836,7 @@
           </a:bodyPr>
           <a:lstStyle/>
           <a:p>
-            <a:pPr>
+            <a:pPr algn="r" rtl="1">
               <a:spcAft>
                 <a:spcPts val="200"/>
               </a:spcAft>
@@ -5844,11 +5844,11 @@
                 <a:solidFill>
                   <a:srgbClr val="18352D"/>
                 </a:solidFill>
-                <a:latin typeface="Aptos"/>
-              </a:defRPr>
-            </a:pPr>
-            <a:r>
-              <a:t>Print or share a document</a:t>
+                <a:latin typeface="Tahoma"/>
+              </a:defRPr>
+            </a:pPr>
+            <a:r>
+              <a:t>پرداخت‌های بعدی را ثبت کنید</a:t>
             </a:r>
           </a:p>
         </p:txBody>
@@ -5875,7 +5875,7 @@
           </a:bodyPr>
           <a:lstStyle/>
           <a:p>
-            <a:pPr>
+            <a:pPr algn="r" rtl="1">
               <a:spcAft>
                 <a:spcPts val="200"/>
               </a:spcAft>
@@ -5883,11 +5883,11 @@
                 <a:solidFill>
                   <a:srgbClr val="66766F"/>
                 </a:solidFill>
-                <a:latin typeface="Aptos"/>
-              </a:defRPr>
-            </a:pPr>
-            <a:r>
-              <a:t>Create A4 invoices, receipts and statements as PDFs.</a:t>
+                <a:latin typeface="Tahoma"/>
+              </a:defRPr>
+            </a:pPr>
+            <a:r>
+              <a:t>با هر رسید، باقی‌داری حساب به‌روز می‌شود.</a:t>
             </a:r>
           </a:p>
         </p:txBody>
@@ -5959,7 +5959,7 @@
           </a:bodyPr>
           <a:lstStyle/>
           <a:p>
-            <a:pPr algn="ctr">
+            <a:pPr algn="ctr" rtl="1">
               <a:spcAft>
                 <a:spcPts val="200"/>
               </a:spcAft>
@@ -5967,7 +5967,7 @@
                 <a:solidFill>
                   <a:srgbClr val="1F5948"/>
                 </a:solidFill>
-                <a:latin typeface="Aptos"/>
+                <a:latin typeface="Tahoma"/>
               </a:defRPr>
             </a:pPr>
             <a:r>
@@ -5998,7 +5998,7 @@
           </a:bodyPr>
           <a:lstStyle/>
           <a:p>
-            <a:pPr>
+            <a:pPr algn="r" rtl="1">
               <a:spcAft>
                 <a:spcPts val="200"/>
               </a:spcAft>
@@ -6006,11 +6006,11 @@
                 <a:solidFill>
                   <a:srgbClr val="18352D"/>
                 </a:solidFill>
-                <a:latin typeface="Aptos"/>
-              </a:defRPr>
-            </a:pPr>
-            <a:r>
-              <a:t>Remember negotiated prices</a:t>
+                <a:latin typeface="Tahoma"/>
+              </a:defRPr>
+            </a:pPr>
+            <a:r>
+              <a:t>بل و رسید آماده کنید</a:t>
             </a:r>
           </a:p>
         </p:txBody>
@@ -6037,7 +6037,7 @@
           </a:bodyPr>
           <a:lstStyle/>
           <a:p>
-            <a:pPr>
+            <a:pPr algn="r" rtl="1">
               <a:spcAft>
                 <a:spcPts val="200"/>
               </a:spcAft>
@@ -6045,11 +6045,11 @@
                 <a:solidFill>
                   <a:srgbClr val="66766F"/>
                 </a:solidFill>
-                <a:latin typeface="Aptos"/>
-              </a:defRPr>
-            </a:pPr>
-            <a:r>
-              <a:t>Review customer price history and suggest a previous rate.</a:t>
+                <a:latin typeface="Tahoma"/>
+              </a:defRPr>
+            </a:pPr>
+            <a:r>
+              <a:t>بل، رسید و صورت‌حساب را PDF کنید؛ اندازهٔ چاپ آن A4 است.</a:t>
             </a:r>
           </a:p>
         </p:txBody>
@@ -6121,7 +6121,7 @@
           </a:bodyPr>
           <a:lstStyle/>
           <a:p>
-            <a:pPr>
+            <a:pPr algn="r" rtl="1">
               <a:spcAft>
                 <a:spcPts val="200"/>
               </a:spcAft>
@@ -6129,11 +6129,11 @@
                 <a:solidFill>
                   <a:srgbClr val="FFFFFF"/>
                 </a:solidFill>
-                <a:latin typeface="Aptos"/>
-              </a:defRPr>
-            </a:pPr>
-            <a:r>
-              <a:t>Clearer conversations</a:t>
+                <a:latin typeface="Tahoma"/>
+              </a:defRPr>
+            </a:pPr>
+            <a:r>
+              <a:t>حساب‌وکتاب روشن‌تر</a:t>
             </a:r>
           </a:p>
         </p:txBody>
@@ -6278,7 +6278,7 @@
           </a:bodyPr>
           <a:lstStyle/>
           <a:p>
-            <a:pPr>
+            <a:pPr algn="r" rtl="1">
               <a:spcAft>
                 <a:spcPts val="200"/>
               </a:spcAft>
@@ -6286,11 +6286,11 @@
                 <a:solidFill>
                   <a:srgbClr val="66766F"/>
                 </a:solidFill>
-                <a:latin typeface="Aptos"/>
-              </a:defRPr>
-            </a:pPr>
-            <a:r>
-              <a:t>Customer statement • purchases, receipts and current balance</a:t>
+                <a:latin typeface="Tahoma"/>
+              </a:defRPr>
+            </a:pPr>
+            <a:r>
+              <a:t>صورت‌حساب مشتری • خریدها، رسیدها و باقی‌داری فعلی</a:t>
             </a:r>
           </a:p>
         </p:txBody>
@@ -6317,7 +6317,7 @@
           </a:bodyPr>
           <a:lstStyle/>
           <a:p>
-            <a:pPr>
+            <a:pPr algn="r" rtl="1">
               <a:spcAft>
                 <a:spcPts val="200"/>
               </a:spcAft>
@@ -6325,11 +6325,11 @@
                 <a:solidFill>
                   <a:srgbClr val="66766F"/>
                 </a:solidFill>
-                <a:latin typeface="Aptos"/>
-              </a:defRPr>
-            </a:pPr>
-            <a:r>
-              <a:t>FLOORING &amp; VINYL STORE MANAGER</a:t>
+                <a:latin typeface="Tahoma"/>
+              </a:defRPr>
+            </a:pPr>
+            <a:r>
+              <a:t>سیستم مدیریت دکان قالین و وینیل</a:t>
             </a:r>
           </a:p>
         </p:txBody>
@@ -6356,7 +6356,7 @@
           </a:bodyPr>
           <a:lstStyle/>
           <a:p>
-            <a:pPr algn="r">
+            <a:pPr algn="r" rtl="1">
               <a:spcAft>
                 <a:spcPts val="200"/>
               </a:spcAft>
@@ -6364,7 +6364,7 @@
                 <a:solidFill>
                   <a:srgbClr val="66766F"/>
                 </a:solidFill>
-                <a:latin typeface="Aptos"/>
+                <a:latin typeface="Tahoma"/>
               </a:defRPr>
             </a:pPr>
             <a:r>
@@ -6421,7 +6421,7 @@
           </a:bodyPr>
           <a:lstStyle/>
           <a:p>
-            <a:pPr>
+            <a:pPr algn="r" rtl="1">
               <a:spcAft>
                 <a:spcPts val="200"/>
               </a:spcAft>
@@ -6429,11 +6429,11 @@
                 <a:solidFill>
                   <a:srgbClr val="1F5948"/>
                 </a:solidFill>
-                <a:latin typeface="Aptos"/>
-              </a:defRPr>
-            </a:pPr>
-            <a:r>
-              <a:t>04  /  SUPPLIER COSTS</a:t>
+                <a:latin typeface="Tahoma"/>
+              </a:defRPr>
+            </a:pPr>
+            <a:r>
+              <a:t>04  /  تهیه‌کنندگان</a:t>
             </a:r>
           </a:p>
         </p:txBody>
@@ -6460,7 +6460,7 @@
           </a:bodyPr>
           <a:lstStyle/>
           <a:p>
-            <a:pPr>
+            <a:pPr algn="r" rtl="1">
               <a:spcAft>
                 <a:spcPts val="200"/>
               </a:spcAft>
@@ -6468,11 +6468,11 @@
                 <a:solidFill>
                   <a:srgbClr val="18352D"/>
                 </a:solidFill>
-                <a:latin typeface="Aptos"/>
-              </a:defRPr>
-            </a:pPr>
-            <a:r>
-              <a:t>See the money behind the stock.</a:t>
+                <a:latin typeface="Tahoma"/>
+              </a:defRPr>
+            </a:pPr>
+            <a:r>
+              <a:t>مصارف خرید و حساب تهیه‌کنندگان را یک‌جا ببینید.</a:t>
             </a:r>
           </a:p>
         </p:txBody>
@@ -6499,7 +6499,7 @@
           </a:bodyPr>
           <a:lstStyle/>
           <a:p>
-            <a:pPr>
+            <a:pPr algn="r" rtl="1">
               <a:spcAft>
                 <a:spcPts val="200"/>
               </a:spcAft>
@@ -6507,11 +6507,11 @@
                 <a:solidFill>
                   <a:srgbClr val="66766F"/>
                 </a:solidFill>
-                <a:latin typeface="Aptos"/>
-              </a:defRPr>
-            </a:pPr>
-            <a:r>
-              <a:t>Connect incoming goods with supplier accounts and the costs that shape your margin.</a:t>
+                <a:latin typeface="Tahoma"/>
+              </a:defRPr>
+            </a:pPr>
+            <a:r>
+              <a:t>جنس‌های وارده را با حساب تهیه‌کننده و مصارف خرید پیوند دهید.</a:t>
             </a:r>
           </a:p>
         </p:txBody>
@@ -6583,7 +6583,7 @@
           </a:bodyPr>
           <a:lstStyle/>
           <a:p>
-            <a:pPr algn="ctr">
+            <a:pPr algn="ctr" rtl="1">
               <a:spcAft>
                 <a:spcPts val="200"/>
               </a:spcAft>
@@ -6591,7 +6591,7 @@
                 <a:solidFill>
                   <a:srgbClr val="1F5948"/>
                 </a:solidFill>
-                <a:latin typeface="Aptos"/>
+                <a:latin typeface="Tahoma"/>
               </a:defRPr>
             </a:pPr>
             <a:r>
@@ -6622,7 +6622,7 @@
           </a:bodyPr>
           <a:lstStyle/>
           <a:p>
-            <a:pPr>
+            <a:pPr algn="r" rtl="1">
               <a:spcAft>
                 <a:spcPts val="200"/>
               </a:spcAft>
@@ -6630,11 +6630,11 @@
                 <a:solidFill>
                   <a:srgbClr val="18352D"/>
                 </a:solidFill>
-                <a:latin typeface="Aptos"/>
-              </a:defRPr>
-            </a:pPr>
-            <a:r>
-              <a:t>Record purchase costs</a:t>
+                <a:latin typeface="Tahoma"/>
+              </a:defRPr>
+            </a:pPr>
+            <a:r>
+              <a:t>مصارف خرید را ثبت کنید</a:t>
             </a:r>
           </a:p>
         </p:txBody>
@@ -6661,7 +6661,7 @@
           </a:bodyPr>
           <a:lstStyle/>
           <a:p>
-            <a:pPr>
+            <a:pPr algn="r" rtl="1">
               <a:spcAft>
                 <a:spcPts val="200"/>
               </a:spcAft>
@@ -6669,11 +6669,11 @@
                 <a:solidFill>
                   <a:srgbClr val="66766F"/>
                 </a:solidFill>
-                <a:latin typeface="Aptos"/>
-              </a:defRPr>
-            </a:pPr>
-            <a:r>
-              <a:t>Capture per-meter cost and additional import costs as stock arrives.</a:t>
+                <a:latin typeface="Tahoma"/>
+              </a:defRPr>
+            </a:pPr>
+            <a:r>
+              <a:t>قیمت خرید فی متر و مصارف اضافی را هنگام ورود جنس بنویسید.</a:t>
             </a:r>
           </a:p>
         </p:txBody>
@@ -6745,7 +6745,7 @@
           </a:bodyPr>
           <a:lstStyle/>
           <a:p>
-            <a:pPr algn="ctr">
+            <a:pPr algn="ctr" rtl="1">
               <a:spcAft>
                 <a:spcPts val="200"/>
               </a:spcAft>
@@ -6753,7 +6753,7 @@
                 <a:solidFill>
                   <a:srgbClr val="1F5948"/>
                 </a:solidFill>
-                <a:latin typeface="Aptos"/>
+                <a:latin typeface="Tahoma"/>
               </a:defRPr>
             </a:pPr>
             <a:r>
@@ -6784,7 +6784,7 @@
           </a:bodyPr>
           <a:lstStyle/>
           <a:p>
-            <a:pPr>
+            <a:pPr algn="r" rtl="1">
               <a:spcAft>
                 <a:spcPts val="200"/>
               </a:spcAft>
@@ -6792,11 +6792,11 @@
                 <a:solidFill>
                   <a:srgbClr val="18352D"/>
                 </a:solidFill>
-                <a:latin typeface="Aptos"/>
-              </a:defRPr>
-            </a:pPr>
-            <a:r>
-              <a:t>Follow supplier accounts</a:t>
+                <a:latin typeface="Tahoma"/>
+              </a:defRPr>
+            </a:pPr>
+            <a:r>
+              <a:t>حساب تهیه‌کننده را دنبال کنید</a:t>
             </a:r>
           </a:p>
         </p:txBody>
@@ -6823,7 +6823,7 @@
           </a:bodyPr>
           <a:lstStyle/>
           <a:p>
-            <a:pPr>
+            <a:pPr algn="r" rtl="1">
               <a:spcAft>
                 <a:spcPts val="200"/>
               </a:spcAft>
@@ -6831,11 +6831,11 @@
                 <a:solidFill>
                   <a:srgbClr val="66766F"/>
                 </a:solidFill>
-                <a:latin typeface="Aptos"/>
-              </a:defRPr>
-            </a:pPr>
-            <a:r>
-              <a:t>Track payments, advances, loans and account statements.</a:t>
+                <a:latin typeface="Tahoma"/>
+              </a:defRPr>
+            </a:pPr>
+            <a:r>
+              <a:t>پرداخت، پیش‌پرداخت، قرض و صورت‌حساب تهیه‌کننده را ثبت کنید.</a:t>
             </a:r>
           </a:p>
         </p:txBody>
@@ -6907,7 +6907,7 @@
           </a:bodyPr>
           <a:lstStyle/>
           <a:p>
-            <a:pPr algn="ctr">
+            <a:pPr algn="ctr" rtl="1">
               <a:spcAft>
                 <a:spcPts val="200"/>
               </a:spcAft>
@@ -6915,7 +6915,7 @@
                 <a:solidFill>
                   <a:srgbClr val="1F5948"/>
                 </a:solidFill>
-                <a:latin typeface="Aptos"/>
+                <a:latin typeface="Tahoma"/>
               </a:defRPr>
             </a:pPr>
             <a:r>
@@ -6946,7 +6946,7 @@
           </a:bodyPr>
           <a:lstStyle/>
           <a:p>
-            <a:pPr>
+            <a:pPr algn="r" rtl="1">
               <a:spcAft>
                 <a:spcPts val="200"/>
               </a:spcAft>
@@ -6954,11 +6954,11 @@
                 <a:solidFill>
                   <a:srgbClr val="18352D"/>
                 </a:solidFill>
-                <a:latin typeface="Aptos"/>
-              </a:defRPr>
-            </a:pPr>
-            <a:r>
-              <a:t>Read reports with cost context</a:t>
+                <a:latin typeface="Tahoma"/>
+              </a:defRPr>
+            </a:pPr>
+            <a:r>
+              <a:t>گزارش را با درنظرداشت مصرف بخوانید</a:t>
             </a:r>
           </a:p>
         </p:txBody>
@@ -6985,7 +6985,7 @@
           </a:bodyPr>
           <a:lstStyle/>
           <a:p>
-            <a:pPr>
+            <a:pPr algn="r" rtl="1">
               <a:spcAft>
                 <a:spcPts val="200"/>
               </a:spcAft>
@@ -6993,11 +6993,11 @@
                 <a:solidFill>
                   <a:srgbClr val="66766F"/>
                 </a:solidFill>
-                <a:latin typeface="Aptos"/>
-              </a:defRPr>
-            </a:pPr>
-            <a:r>
-              <a:t>Gross profit uses saved purchase costs; missing costs stay clearly marked.</a:t>
+                <a:latin typeface="Tahoma"/>
+              </a:defRPr>
+            </a:pPr>
+            <a:r>
+              <a:t>سود ناخالص از قیمت خرید ثبت‌شده حساب می‌شود؛ هزینهٔ نامعلوم مشخص می‌ماند.</a:t>
             </a:r>
           </a:p>
         </p:txBody>
@@ -7069,7 +7069,7 @@
           </a:bodyPr>
           <a:lstStyle/>
           <a:p>
-            <a:pPr>
+            <a:pPr algn="r" rtl="1">
               <a:spcAft>
                 <a:spcPts val="200"/>
               </a:spcAft>
@@ -7077,11 +7077,11 @@
                 <a:solidFill>
                   <a:srgbClr val="FFFFFF"/>
                 </a:solidFill>
-                <a:latin typeface="Aptos"/>
-              </a:defRPr>
-            </a:pPr>
-            <a:r>
-              <a:t>Better cost visibility</a:t>
+                <a:latin typeface="Tahoma"/>
+              </a:defRPr>
+            </a:pPr>
+            <a:r>
+              <a:t>آگاهی بهتر از مصارف</a:t>
             </a:r>
           </a:p>
         </p:txBody>
@@ -7226,7 +7226,7 @@
           </a:bodyPr>
           <a:lstStyle/>
           <a:p>
-            <a:pPr>
+            <a:pPr algn="r" rtl="1">
               <a:spcAft>
                 <a:spcPts val="200"/>
               </a:spcAft>
@@ -7234,11 +7234,11 @@
                 <a:solidFill>
                   <a:srgbClr val="66766F"/>
                 </a:solidFill>
-                <a:latin typeface="Aptos"/>
-              </a:defRPr>
-            </a:pPr>
-            <a:r>
-              <a:t>Supplier workflow • account details and activity on mobile</a:t>
+                <a:latin typeface="Tahoma"/>
+              </a:defRPr>
+            </a:pPr>
+            <a:r>
+              <a:t>حساب تهیه‌کننده • جزئیات و فعالیت در موبایل</a:t>
             </a:r>
           </a:p>
         </p:txBody>
@@ -7265,7 +7265,7 @@
           </a:bodyPr>
           <a:lstStyle/>
           <a:p>
-            <a:pPr>
+            <a:pPr algn="r" rtl="1">
               <a:spcAft>
                 <a:spcPts val="200"/>
               </a:spcAft>
@@ -7273,11 +7273,11 @@
                 <a:solidFill>
                   <a:srgbClr val="66766F"/>
                 </a:solidFill>
-                <a:latin typeface="Aptos"/>
-              </a:defRPr>
-            </a:pPr>
-            <a:r>
-              <a:t>FLOORING &amp; VINYL STORE MANAGER</a:t>
+                <a:latin typeface="Tahoma"/>
+              </a:defRPr>
+            </a:pPr>
+            <a:r>
+              <a:t>سیستم مدیریت دکان قالین و وینیل</a:t>
             </a:r>
           </a:p>
         </p:txBody>
@@ -7304,7 +7304,7 @@
           </a:bodyPr>
           <a:lstStyle/>
           <a:p>
-            <a:pPr algn="r">
+            <a:pPr algn="r" rtl="1">
               <a:spcAft>
                 <a:spcPts val="200"/>
               </a:spcAft>
@@ -7312,7 +7312,7 @@
                 <a:solidFill>
                   <a:srgbClr val="66766F"/>
                 </a:solidFill>
-                <a:latin typeface="Aptos"/>
+                <a:latin typeface="Tahoma"/>
               </a:defRPr>
             </a:pPr>
             <a:r>
@@ -7369,7 +7369,7 @@
           </a:bodyPr>
           <a:lstStyle/>
           <a:p>
-            <a:pPr>
+            <a:pPr algn="r" rtl="1">
               <a:spcAft>
                 <a:spcPts val="200"/>
               </a:spcAft>
@@ -7377,11 +7377,11 @@
                 <a:solidFill>
                   <a:srgbClr val="1F5948"/>
                 </a:solidFill>
-                <a:latin typeface="Aptos"/>
-              </a:defRPr>
-            </a:pPr>
-            <a:r>
-              <a:t>05  /  EVERYDAY USE</a:t>
+                <a:latin typeface="Tahoma"/>
+              </a:defRPr>
+            </a:pPr>
+            <a:r>
+              <a:t>05  /  کار روزمره</a:t>
             </a:r>
           </a:p>
         </p:txBody>
@@ -7408,7 +7408,7 @@
           </a:bodyPr>
           <a:lstStyle/>
           <a:p>
-            <a:pPr>
+            <a:pPr algn="r" rtl="1">
               <a:spcAft>
                 <a:spcPts val="200"/>
               </a:spcAft>
@@ -7416,11 +7416,11 @@
                 <a:solidFill>
                   <a:srgbClr val="18352D"/>
                 </a:solidFill>
-                <a:latin typeface="Aptos"/>
-              </a:defRPr>
-            </a:pPr>
-            <a:r>
-              <a:t>Built around a working shop.</a:t>
+                <a:latin typeface="Tahoma"/>
+              </a:defRPr>
+            </a:pPr>
+            <a:r>
+              <a:t>برای کار روزمرهٔ یک دکان ساخته شده.</a:t>
             </a:r>
           </a:p>
         </p:txBody>
@@ -7447,7 +7447,7 @@
           </a:bodyPr>
           <a:lstStyle/>
           <a:p>
-            <a:pPr>
+            <a:pPr algn="r" rtl="1">
               <a:spcAft>
                 <a:spcPts val="200"/>
               </a:spcAft>
@@ -7455,11 +7455,11 @@
                 <a:solidFill>
                   <a:srgbClr val="66766F"/>
                 </a:solidFill>
-                <a:latin typeface="Aptos"/>
-              </a:defRPr>
-            </a:pPr>
-            <a:r>
-              <a:t>Practical tools for the people taking orders, managing stock and keeping the books.</a:t>
+                <a:latin typeface="Tahoma"/>
+              </a:defRPr>
+            </a:pPr>
+            <a:r>
+              <a:t>ابزارهای ساده برای ثبت سفارش، مدیریت موجودی و حساب‌وکتاب دکان.</a:t>
             </a:r>
           </a:p>
         </p:txBody>
@@ -7531,7 +7531,7 @@
           </a:bodyPr>
           <a:lstStyle/>
           <a:p>
-            <a:pPr algn="ctr">
+            <a:pPr algn="ctr" rtl="1">
               <a:spcAft>
                 <a:spcPts val="200"/>
               </a:spcAft>
@@ -7539,7 +7539,7 @@
                 <a:solidFill>
                   <a:srgbClr val="1F5948"/>
                 </a:solidFill>
-                <a:latin typeface="Aptos"/>
+                <a:latin typeface="Tahoma"/>
               </a:defRPr>
             </a:pPr>
             <a:r>
@@ -7570,7 +7570,7 @@
           </a:bodyPr>
           <a:lstStyle/>
           <a:p>
-            <a:pPr>
+            <a:pPr algn="r" rtl="1">
               <a:spcAft>
                 <a:spcPts val="200"/>
               </a:spcAft>
@@ -7578,11 +7578,11 @@
                 <a:solidFill>
                   <a:srgbClr val="18352D"/>
                 </a:solidFill>
-                <a:latin typeface="Aptos"/>
-              </a:defRPr>
-            </a:pPr>
-            <a:r>
-              <a:t>A Dari, right-to-left interface</a:t>
+                <a:latin typeface="Tahoma"/>
+              </a:defRPr>
+            </a:pPr>
+            <a:r>
+              <a:t>صفحه‌ها و اسناد به زبان دری</a:t>
             </a:r>
           </a:p>
         </p:txBody>
@@ -7609,7 +7609,7 @@
           </a:bodyPr>
           <a:lstStyle/>
           <a:p>
-            <a:pPr>
+            <a:pPr algn="r" rtl="1">
               <a:spcAft>
                 <a:spcPts val="200"/>
               </a:spcAft>
@@ -7617,11 +7617,11 @@
                 <a:solidFill>
                   <a:srgbClr val="66766F"/>
                 </a:solidFill>
-                <a:latin typeface="Aptos"/>
-              </a:defRPr>
-            </a:pPr>
-            <a:r>
-              <a:t>The app’s screens and printed documents are designed for Dari workflows.</a:t>
+                <a:latin typeface="Tahoma"/>
+              </a:defRPr>
+            </a:pPr>
+            <a:r>
+              <a:t>رابط کاربری راست‌به‌چپ و اسناد چاپی به زبان دری هستند.</a:t>
             </a:r>
           </a:p>
         </p:txBody>
@@ -7693,7 +7693,7 @@
           </a:bodyPr>
           <a:lstStyle/>
           <a:p>
-            <a:pPr algn="ctr">
+            <a:pPr algn="ctr" rtl="1">
               <a:spcAft>
                 <a:spcPts val="200"/>
               </a:spcAft>
@@ -7701,7 +7701,7 @@
                 <a:solidFill>
                   <a:srgbClr val="1F5948"/>
                 </a:solidFill>
-                <a:latin typeface="Aptos"/>
+                <a:latin typeface="Tahoma"/>
               </a:defRPr>
             </a:pPr>
             <a:r>
@@ -7732,7 +7732,7 @@
           </a:bodyPr>
           <a:lstStyle/>
           <a:p>
-            <a:pPr>
+            <a:pPr algn="r" rtl="1">
               <a:spcAft>
                 <a:spcPts val="200"/>
               </a:spcAft>
@@ -7740,11 +7740,11 @@
                 <a:solidFill>
                   <a:srgbClr val="18352D"/>
                 </a:solidFill>
-                <a:latin typeface="Aptos"/>
-              </a:defRPr>
-            </a:pPr>
-            <a:r>
-              <a:t>Works on desktop and mobile</a:t>
+                <a:latin typeface="Tahoma"/>
+              </a:defRPr>
+            </a:pPr>
+            <a:r>
+              <a:t>در کمپیوتر و موبایل کار می‌کند</a:t>
             </a:r>
           </a:p>
         </p:txBody>
@@ -7771,7 +7771,7 @@
           </a:bodyPr>
           <a:lstStyle/>
           <a:p>
-            <a:pPr>
+            <a:pPr algn="r" rtl="1">
               <a:spcAft>
                 <a:spcPts val="200"/>
               </a:spcAft>
@@ -7779,11 +7779,11 @@
                 <a:solidFill>
                   <a:srgbClr val="66766F"/>
                 </a:solidFill>
-                <a:latin typeface="Aptos"/>
-              </a:defRPr>
-            </a:pPr>
-            <a:r>
-              <a:t>Responsive screens keep core store tasks close at hand.</a:t>
+                <a:latin typeface="Tahoma"/>
+              </a:defRPr>
+            </a:pPr>
+            <a:r>
+              <a:t>صفحه‌ها برای انجام کارهای اصلی دکان در هر دو آماده‌اند.</a:t>
             </a:r>
           </a:p>
         </p:txBody>
@@ -7855,7 +7855,7 @@
           </a:bodyPr>
           <a:lstStyle/>
           <a:p>
-            <a:pPr algn="ctr">
+            <a:pPr algn="ctr" rtl="1">
               <a:spcAft>
                 <a:spcPts val="200"/>
               </a:spcAft>
@@ -7863,7 +7863,7 @@
                 <a:solidFill>
                   <a:srgbClr val="1F5948"/>
                 </a:solidFill>
-                <a:latin typeface="Aptos"/>
+                <a:latin typeface="Tahoma"/>
               </a:defRPr>
             </a:pPr>
             <a:r>
@@ -7894,7 +7894,7 @@
           </a:bodyPr>
           <a:lstStyle/>
           <a:p>
-            <a:pPr>
+            <a:pPr algn="r" rtl="1">
               <a:spcAft>
                 <a:spcPts val="200"/>
               </a:spcAft>
@@ -7902,11 +7902,11 @@
                 <a:solidFill>
                   <a:srgbClr val="18352D"/>
                 </a:solidFill>
-                <a:latin typeface="Aptos"/>
-              </a:defRPr>
-            </a:pPr>
-            <a:r>
-              <a:t>Access by role</a:t>
+                <a:latin typeface="Tahoma"/>
+              </a:defRPr>
+            </a:pPr>
+            <a:r>
+              <a:t>دسترسی بر اساس وظیفه</a:t>
             </a:r>
           </a:p>
         </p:txBody>
@@ -7933,7 +7933,7 @@
           </a:bodyPr>
           <a:lstStyle/>
           <a:p>
-            <a:pPr>
+            <a:pPr algn="r" rtl="1">
               <a:spcAft>
                 <a:spcPts val="200"/>
               </a:spcAft>
@@ -7941,11 +7941,11 @@
                 <a:solidFill>
                   <a:srgbClr val="66766F"/>
                 </a:solidFill>
-                <a:latin typeface="Aptos"/>
-              </a:defRPr>
-            </a:pPr>
-            <a:r>
-              <a:t>Admin, manager and staff permissions help each person see the tools they need.</a:t>
+                <a:latin typeface="Tahoma"/>
+              </a:defRPr>
+            </a:pPr>
+            <a:r>
+              <a:t>نقش‌های مدیر سیستم، مدیر و کارمند دسترسی هر شخص را تنظیم می‌کنند.</a:t>
             </a:r>
           </a:p>
         </p:txBody>
@@ -8017,7 +8017,7 @@
           </a:bodyPr>
           <a:lstStyle/>
           <a:p>
-            <a:pPr>
+            <a:pPr algn="r" rtl="1">
               <a:spcAft>
                 <a:spcPts val="200"/>
               </a:spcAft>
@@ -8025,11 +8025,11 @@
                 <a:solidFill>
                   <a:srgbClr val="FFFFFF"/>
                 </a:solidFill>
-                <a:latin typeface="Aptos"/>
-              </a:defRPr>
-            </a:pPr>
-            <a:r>
-              <a:t>Ready for daily work</a:t>
+                <a:latin typeface="Tahoma"/>
+              </a:defRPr>
+            </a:pPr>
+            <a:r>
+              <a:t>آمادهٔ استفادهٔ روزانه</a:t>
             </a:r>
           </a:p>
         </p:txBody>
@@ -8174,7 +8174,7 @@
           </a:bodyPr>
           <a:lstStyle/>
           <a:p>
-            <a:pPr>
+            <a:pPr algn="r" rtl="1">
               <a:spcAft>
                 <a:spcPts val="200"/>
               </a:spcAft>
@@ -8182,11 +8182,11 @@
                 <a:solidFill>
                   <a:srgbClr val="66766F"/>
                 </a:solidFill>
-                <a:latin typeface="Aptos"/>
-              </a:defRPr>
-            </a:pPr>
-            <a:r>
-              <a:t>Printable receipt • a consistent A4 document for customers</a:t>
+                <a:latin typeface="Tahoma"/>
+              </a:defRPr>
+            </a:pPr>
+            <a:r>
+              <a:t>رسید چاپی • سند A4 برای شریک‌ساختن با مشتری</a:t>
             </a:r>
           </a:p>
         </p:txBody>
@@ -8213,7 +8213,7 @@
           </a:bodyPr>
           <a:lstStyle/>
           <a:p>
-            <a:pPr>
+            <a:pPr algn="r" rtl="1">
               <a:spcAft>
                 <a:spcPts val="200"/>
               </a:spcAft>
@@ -8221,11 +8221,11 @@
                 <a:solidFill>
                   <a:srgbClr val="66766F"/>
                 </a:solidFill>
-                <a:latin typeface="Aptos"/>
-              </a:defRPr>
-            </a:pPr>
-            <a:r>
-              <a:t>FLOORING &amp; VINYL STORE MANAGER</a:t>
+                <a:latin typeface="Tahoma"/>
+              </a:defRPr>
+            </a:pPr>
+            <a:r>
+              <a:t>سیستم مدیریت دکان قالین و وینیل</a:t>
             </a:r>
           </a:p>
         </p:txBody>
@@ -8252,7 +8252,7 @@
           </a:bodyPr>
           <a:lstStyle/>
           <a:p>
-            <a:pPr algn="r">
+            <a:pPr algn="r" rtl="1">
               <a:spcAft>
                 <a:spcPts val="200"/>
               </a:spcAft>
@@ -8260,7 +8260,7 @@
                 <a:solidFill>
                   <a:srgbClr val="66766F"/>
                 </a:solidFill>
-                <a:latin typeface="Aptos"/>
+                <a:latin typeface="Tahoma"/>
               </a:defRPr>
             </a:pPr>
             <a:r>
@@ -8317,7 +8317,7 @@
           </a:bodyPr>
           <a:lstStyle/>
           <a:p>
-            <a:pPr>
+            <a:pPr algn="r" rtl="1">
               <a:spcAft>
                 <a:spcPts val="200"/>
               </a:spcAft>
@@ -8325,11 +8325,11 @@
                 <a:solidFill>
                   <a:srgbClr val="B7CCBE"/>
                 </a:solidFill>
-                <a:latin typeface="Aptos"/>
-              </a:defRPr>
-            </a:pPr>
-            <a:r>
-              <a:t>A PRACTICAL UPGRADE FOR YOUR STORE</a:t>
+                <a:latin typeface="Tahoma"/>
+              </a:defRPr>
+            </a:pPr>
+            <a:r>
+              <a:t>یک گام عملی برای دکان شما</a:t>
             </a:r>
           </a:p>
         </p:txBody>
@@ -8356,7 +8356,7 @@
           </a:bodyPr>
           <a:lstStyle/>
           <a:p>
-            <a:pPr>
+            <a:pPr algn="r" rtl="1">
               <a:spcAft>
                 <a:spcPts val="200"/>
               </a:spcAft>
@@ -8364,11 +8364,11 @@
                 <a:solidFill>
                   <a:srgbClr val="FFFFFF"/>
                 </a:solidFill>
-                <a:latin typeface="Aptos"/>
-              </a:defRPr>
-            </a:pPr>
-            <a:r>
-              <a:t>Spend less time piecing records together.</a:t>
+                <a:latin typeface="Tahoma"/>
+              </a:defRPr>
+            </a:pPr>
+            <a:r>
+              <a:t>کارهای دکان‌تان را منظم‌تر پیش ببرید.</a:t>
             </a:r>
           </a:p>
         </p:txBody>
@@ -8395,7 +8395,7 @@
           </a:bodyPr>
           <a:lstStyle/>
           <a:p>
-            <a:pPr>
+            <a:pPr algn="r" rtl="1">
               <a:spcAft>
                 <a:spcPts val="200"/>
               </a:spcAft>
@@ -8403,11 +8403,11 @@
                 <a:solidFill>
                   <a:srgbClr val="D7E6DC"/>
                 </a:solidFill>
-                <a:latin typeface="Aptos"/>
-              </a:defRPr>
-            </a:pPr>
-            <a:r>
-              <a:t>Bring stock, sales, customer balances and supplier costs into one daily workflow.</a:t>
+                <a:latin typeface="Tahoma"/>
+              </a:defRPr>
+            </a:pPr>
+            <a:r>
+              <a:t>موجودی، فروشات، حساب مشتریان و مصارف تهیه‌کنندگان را در یک جریان کاری مدیریت کنید.</a:t>
             </a:r>
           </a:p>
         </p:txBody>
@@ -8479,7 +8479,7 @@
           </a:bodyPr>
           <a:lstStyle/>
           <a:p>
-            <a:pPr>
+            <a:pPr algn="r" rtl="1">
               <a:spcAft>
                 <a:spcPts val="200"/>
               </a:spcAft>
@@ -8487,11 +8487,11 @@
                 <a:solidFill>
                   <a:srgbClr val="FFFFFF"/>
                 </a:solidFill>
-                <a:latin typeface="Aptos"/>
-              </a:defRPr>
-            </a:pPr>
-            <a:r>
-              <a:t>Let’s walk through your store’s workflow.</a:t>
+                <a:latin typeface="Tahoma"/>
+              </a:defRPr>
+            </a:pPr>
+            <a:r>
+              <a:t>بیایید کار روزمرهٔ دکان‌تان را باهم مرور کنیم.</a:t>
             </a:r>
           </a:p>
         </p:txBody>
@@ -8518,7 +8518,7 @@
           </a:bodyPr>
           <a:lstStyle/>
           <a:p>
-            <a:pPr>
+            <a:pPr algn="r" rtl="1">
               <a:spcAft>
                 <a:spcPts val="200"/>
               </a:spcAft>
@@ -8526,11 +8526,11 @@
                 <a:solidFill>
                   <a:srgbClr val="C1D1C7"/>
                 </a:solidFill>
-                <a:latin typeface="Aptos"/>
-              </a:defRPr>
-            </a:pPr>
-            <a:r>
-              <a:t>Your name  •  Phone / WhatsApp  •  Email</a:t>
+                <a:latin typeface="Tahoma"/>
+              </a:defRPr>
+            </a:pPr>
+            <a:r>
+              <a:t>نام شما  •  شماره تماس / واتس‌اپ  •  ایمیل</a:t>
             </a:r>
           </a:p>
         </p:txBody>
@@ -8628,7 +8628,7 @@
           </a:bodyPr>
           <a:lstStyle/>
           <a:p>
-            <a:pPr>
+            <a:pPr algn="r" rtl="1">
               <a:spcAft>
                 <a:spcPts val="200"/>
               </a:spcAft>
@@ -8636,11 +8636,11 @@
                 <a:solidFill>
                   <a:srgbClr val="A8C1B1"/>
                 </a:solidFill>
-                <a:latin typeface="Aptos"/>
-              </a:defRPr>
-            </a:pPr>
-            <a:r>
-              <a:t>YOUR CONTACT DETAILS</a:t>
+                <a:latin typeface="Tahoma"/>
+              </a:defRPr>
+            </a:pPr>
+            <a:r>
+              <a:t>معلومات تماس خود را این‌جا بنویسید</a:t>
             </a:r>
           </a:p>
         </p:txBody>
@@ -8667,7 +8667,7 @@
           </a:bodyPr>
           <a:lstStyle/>
           <a:p>
-            <a:pPr algn="r">
+            <a:pPr algn="r" rtl="1">
               <a:spcAft>
                 <a:spcPts val="200"/>
               </a:spcAft>
@@ -8675,7 +8675,7 @@
                 <a:solidFill>
                   <a:srgbClr val="A8C1B1"/>
                 </a:solidFill>
-                <a:latin typeface="Aptos"/>
+                <a:latin typeface="Tahoma"/>
               </a:defRPr>
             </a:pPr>
             <a:r>

</xml_diff>